<commit_message>
Rebuild per-day PDFs and PPTX (600 files) with substantive Core content
300 per-day PDFs and 300 per-day PPTX regenerated for the 10 new modules
across all 3 bands. Each day now reflects the substantive Core content
that replaced the previous template placeholders.

Co-Authored-By: Claude Opus 4.7 (1M context) <noreply@anthropic.com>
</commit_message>
<xml_diff>
--- a/exports/pptx/lessons/middle-module-13-indic-ecology/day-10-project-pitch.pptx
+++ b/exports/pptx/lessons/middle-module-13-indic-ecology/day-10-project-pitch.pptx
@@ -3626,7 +3626,7 @@
         <p:spPr>
           <a:xfrm>
             <a:off x="634901" y="883593"/>
-            <a:ext cx="8102798" cy="1462683"/>
+            <a:ext cx="8102798" cy="487561"/>
           </a:xfrm>
           <a:prstGeom prst="rect">
             <a:avLst/>
@@ -3657,7 +3657,7 @@
                 <a:ea typeface="Arial" pitchFamily="34" charset="-122"/>
                 <a:cs typeface="Arial" pitchFamily="34" charset="-120"/>
               </a:rPr>
-              <a:t>State the observable phenomenon first.</a:t>
+              <a:t>Project pitches (3 min each).</a:t>
             </a:r>
             <a:pPr algn="l" indent="0" marL="0">
               <a:lnSpc>
@@ -3677,10 +3677,32 @@
                 <a:ea typeface="Arial" pitchFamily="34" charset="-122"/>
                 <a:cs typeface="Arial" pitchFamily="34" charset="-120"/>
               </a:rPr>
-              <a:t> Whatever the day's idea is — a number trick, a celestial pattern, a herb's identifying feature — start with the thing students can see, hear, or do.</a:t>
+              <a:t> Each student presents their environmental-action project: problem identified, principle anchored, plan, expected outcome, measurement.</a:t>
             </a:r>
             <a:endParaRPr lang="en-US" sz="1200" dirty="0"/>
           </a:p>
+        </p:txBody>
+      </p:sp>
+      <p:sp>
+        <p:nvSpPr>
+          <p:cNvPr id="5" name="Text 3"/>
+          <p:cNvSpPr/>
+          <p:nvPr/>
+        </p:nvSpPr>
+        <p:spPr>
+          <a:xfrm>
+            <a:off x="634901" y="1472654"/>
+            <a:ext cx="8102798" cy="281880"/>
+          </a:xfrm>
+          <a:prstGeom prst="rect">
+            <a:avLst/>
+          </a:prstGeom>
+          <a:noFill/>
+          <a:ln/>
+        </p:spPr>
+        <p:txBody>
+          <a:bodyPr wrap="square" lIns="0" tIns="0" rIns="0" bIns="0" rtlCol="0" anchor="t"/>
+          <a:lstStyle/>
           <a:p>
             <a:pPr algn="l" marL="342900" indent="-342900">
               <a:lnSpc>
@@ -3701,7 +3723,7 @@
                 <a:ea typeface="Arial" pitchFamily="34" charset="-122"/>
                 <a:cs typeface="Arial" pitchFamily="34" charset="-120"/>
               </a:rPr>
-              <a:t>Introduce the Sanskrit term.</a:t>
+              <a:t>Q&amp;A and feedback (1 min each).</a:t>
             </a:r>
             <a:pPr algn="l" indent="0" marL="0">
               <a:lnSpc>
@@ -3721,10 +3743,32 @@
                 <a:ea typeface="Arial" pitchFamily="34" charset="-122"/>
                 <a:cs typeface="Arial" pitchFamily="34" charset="-120"/>
               </a:rPr>
-              <a:t> Once, in the triple format, then italicised only.</a:t>
+              <a:t> Peers ask one question and offer one suggestion.</a:t>
             </a:r>
             <a:endParaRPr lang="en-US" sz="1200" dirty="0"/>
           </a:p>
+        </p:txBody>
+      </p:sp>
+      <p:sp>
+        <p:nvSpPr>
+          <p:cNvPr id="6" name="Text 4"/>
+          <p:cNvSpPr/>
+          <p:nvPr/>
+        </p:nvSpPr>
+        <p:spPr>
+          <a:xfrm>
+            <a:off x="634901" y="1856036"/>
+            <a:ext cx="8102798" cy="281880"/>
+          </a:xfrm>
+          <a:prstGeom prst="rect">
+            <a:avLst/>
+          </a:prstGeom>
+          <a:noFill/>
+          <a:ln/>
+        </p:spPr>
+        <p:txBody>
+          <a:bodyPr wrap="square" lIns="0" tIns="0" rIns="0" bIns="0" rtlCol="0" anchor="t"/>
+          <a:lstStyle/>
           <a:p>
             <a:pPr algn="l" marL="342900" indent="-342900">
               <a:lnSpc>
@@ -3745,7 +3789,7 @@
                 <a:ea typeface="Arial" pitchFamily="34" charset="-122"/>
                 <a:cs typeface="Arial" pitchFamily="34" charset="-120"/>
               </a:rPr>
-              <a:t>Build the conceptual map.</a:t>
+              <a:t>Voting.</a:t>
             </a:r>
             <a:pPr algn="l" indent="0" marL="0">
               <a:lnSpc>
@@ -3765,10 +3809,32 @@
                 <a:ea typeface="Arial" pitchFamily="34" charset="-122"/>
                 <a:cs typeface="Arial" pitchFamily="34" charset="-120"/>
               </a:rPr>
-              <a:t> Connect today's idea to prior modules (especially Module 2 if applicable) and prior days.</a:t>
+              <a:t> Class votes on 3 favourite projects. These will be amplified (school-wide, parent-day presentations).</a:t>
             </a:r>
             <a:endParaRPr lang="en-US" sz="1200" dirty="0"/>
           </a:p>
+        </p:txBody>
+      </p:sp>
+      <p:sp>
+        <p:nvSpPr>
+          <p:cNvPr id="7" name="Text 5"/>
+          <p:cNvSpPr/>
+          <p:nvPr/>
+        </p:nvSpPr>
+        <p:spPr>
+          <a:xfrm>
+            <a:off x="634901" y="2239417"/>
+            <a:ext cx="8102798" cy="300930"/>
+          </a:xfrm>
+          <a:prstGeom prst="rect">
+            <a:avLst/>
+          </a:prstGeom>
+          <a:noFill/>
+          <a:ln/>
+        </p:spPr>
+        <p:txBody>
+          <a:bodyPr wrap="square" lIns="0" tIns="0" rIns="0" bIns="0" rtlCol="0" anchor="t"/>
+          <a:lstStyle/>
           <a:p>
             <a:pPr algn="l" marL="342900" indent="-342900">
               <a:lnSpc>
@@ -3789,7 +3855,7 @@
                 <a:ea typeface="Arial" pitchFamily="34" charset="-122"/>
                 <a:cs typeface="Arial" pitchFamily="34" charset="-120"/>
               </a:rPr>
-              <a:t>Work an example</a:t>
+              <a:t>Summative quiz (20 min).</a:t>
             </a:r>
             <a:pPr algn="l" indent="0" marL="0">
               <a:lnSpc>
@@ -3809,10 +3875,72 @@
                 <a:ea typeface="Arial" pitchFamily="34" charset="-122"/>
                 <a:cs typeface="Arial" pitchFamily="34" charset="-120"/>
               </a:rPr>
-              <a:t> with the whole class on the board.</a:t>
+              <a:t> See </a:t>
+            </a:r>
+            <a:pPr algn="l" indent="0" marL="0">
+              <a:lnSpc>
+                <a:spcPts val="1620"/>
+              </a:lnSpc>
+              <a:spcAft>
+                <a:spcPts val="300"/>
+              </a:spcAft>
+              <a:buNone/>
+            </a:pPr>
+            <a:r>
+              <a:rPr lang="en-US" sz="1200" dirty="0">
+                <a:solidFill>
+                  <a:srgbClr val="1C2833"/>
+                </a:solidFill>
+                <a:latin typeface="Arial" pitchFamily="34" charset="0"/>
+                <a:ea typeface="Arial" pitchFamily="34" charset="-122"/>
+                <a:cs typeface="Arial" pitchFamily="34" charset="-120"/>
+              </a:rPr>
+              <a:t>quizzes/summative.md</a:t>
+            </a:r>
+            <a:pPr algn="l" indent="0" marL="0">
+              <a:lnSpc>
+                <a:spcPts val="1620"/>
+              </a:lnSpc>
+              <a:spcAft>
+                <a:spcPts val="300"/>
+              </a:spcAft>
+              <a:buNone/>
+            </a:pPr>
+            <a:r>
+              <a:rPr lang="en-US" sz="1200" dirty="0">
+                <a:solidFill>
+                  <a:srgbClr val="1C2833"/>
+                </a:solidFill>
+                <a:latin typeface="Arial" pitchFamily="34" charset="0"/>
+                <a:ea typeface="Arial" pitchFamily="34" charset="-122"/>
+                <a:cs typeface="Arial" pitchFamily="34" charset="-120"/>
+              </a:rPr>
+              <a:t>.</a:t>
             </a:r>
             <a:endParaRPr lang="en-US" sz="1200" dirty="0"/>
           </a:p>
+        </p:txBody>
+      </p:sp>
+      <p:sp>
+        <p:nvSpPr>
+          <p:cNvPr id="8" name="Text 6"/>
+          <p:cNvSpPr/>
+          <p:nvPr/>
+        </p:nvSpPr>
+        <p:spPr>
+          <a:xfrm>
+            <a:off x="634901" y="2641848"/>
+            <a:ext cx="8102798" cy="487561"/>
+          </a:xfrm>
+          <a:prstGeom prst="rect">
+            <a:avLst/>
+          </a:prstGeom>
+          <a:noFill/>
+          <a:ln/>
+        </p:spPr>
+        <p:txBody>
+          <a:bodyPr wrap="square" lIns="0" tIns="0" rIns="0" bIns="0" rtlCol="0" anchor="t"/>
+          <a:lstStyle/>
           <a:p>
             <a:pPr algn="l" marL="342900" indent="-342900">
               <a:lnSpc>
@@ -3833,7 +3961,7 @@
                 <a:ea typeface="Arial" pitchFamily="34" charset="-122"/>
                 <a:cs typeface="Arial" pitchFamily="34" charset="-120"/>
               </a:rPr>
-              <a:t>Independent or paired practice</a:t>
+              <a:t>Module close.</a:t>
             </a:r>
             <a:pPr algn="l" indent="0" marL="0">
               <a:lnSpc>
@@ -3853,7 +3981,47 @@
                 <a:ea typeface="Arial" pitchFamily="34" charset="-122"/>
                 <a:cs typeface="Arial" pitchFamily="34" charset="-120"/>
               </a:rPr>
-              <a:t> for ~5 minutes.</a:t>
+              <a:t> </a:t>
+            </a:r>
+            <a:pPr algn="l" indent="0" marL="0">
+              <a:lnSpc>
+                <a:spcPts val="1620"/>
+              </a:lnSpc>
+              <a:spcAft>
+                <a:spcPts val="300"/>
+              </a:spcAft>
+              <a:buNone/>
+            </a:pPr>
+            <a:r>
+              <a:rPr lang="en-US" sz="1200" i="1" dirty="0">
+                <a:solidFill>
+                  <a:srgbClr val="1C2833"/>
+                </a:solidFill>
+                <a:latin typeface="Arial" pitchFamily="34" charset="0"/>
+                <a:ea typeface="Arial" pitchFamily="34" charset="-122"/>
+                <a:cs typeface="Arial" pitchFamily="34" charset="-120"/>
+              </a:rPr>
+              <a:t>"Of all the texts and ideas in this module, which one will stay with you the longest? Why?"</a:t>
+            </a:r>
+            <a:pPr algn="l" indent="0" marL="0">
+              <a:lnSpc>
+                <a:spcPts val="1620"/>
+              </a:lnSpc>
+              <a:spcAft>
+                <a:spcPts val="300"/>
+              </a:spcAft>
+              <a:buNone/>
+            </a:pPr>
+            <a:r>
+              <a:rPr lang="en-US" sz="1200" dirty="0">
+                <a:solidFill>
+                  <a:srgbClr val="1C2833"/>
+                </a:solidFill>
+                <a:latin typeface="Arial" pitchFamily="34" charset="0"/>
+                <a:ea typeface="Arial" pitchFamily="34" charset="-122"/>
+                <a:cs typeface="Arial" pitchFamily="34" charset="-120"/>
+              </a:rPr>
+              <a:t> Each student writes 2 sentences.</a:t>
             </a:r>
             <a:endParaRPr lang="en-US" sz="1200" dirty="0"/>
           </a:p>
@@ -3861,7 +4029,7 @@
       </p:sp>
       <p:sp>
         <p:nvSpPr>
-          <p:cNvPr id="5" name="Text 3"/>
+          <p:cNvPr id="9" name="Text 7"/>
           <p:cNvSpPr/>
           <p:nvPr/>
         </p:nvSpPr>

</xml_diff>